<commit_message>
명칭 통일 — 잔여 'Smart WMS Agent' → WOONG AI
- UI: 사이드바 사용자명 'Smart Admin'→'WOONG Admin'(아바타 SA→WA).
- 덱(make_deck.js): 슬라이드 브랜드 텍스트 5곳 WOONG AI로 변경, pptx 재생성.
- 문서(01_PRD·02_AGENT_ARCHITECTURE): 제목·본문 브랜드명 WOONG AI로 변경.
- 파일명(Smart_WMS_Agent_*.pptx)·폴더명·deprecated make_status_deck.js는 구조/미사용이라 보존.

Co-Authored-By: Claude Opus 4.8 <noreply@anthropic.com>
</commit_message>
<xml_diff>
--- a/Smart_WMS_Agent_기획요약.pptx
+++ b/Smart_WMS_Agent_기획요약.pptx
@@ -2994,7 +2994,7 @@
                 <a:ea typeface="Malgun Gothic" pitchFamily="34" charset="-122"/>
                 <a:cs typeface="Malgun Gothic" pitchFamily="34" charset="-120"/>
               </a:rPr>
-              <a:t>Smart WMS Agent</a:t>
+              <a:t>WOONG AI</a:t>
             </a:r>
             <a:endParaRPr lang="en-US" sz="4800" dirty="0"/>
           </a:p>
@@ -3752,7 +3752,7 @@
                 <a:ea typeface="Malgun Gothic" pitchFamily="34" charset="-122"/>
                 <a:cs typeface="Malgun Gothic" pitchFamily="34" charset="-120"/>
               </a:rPr>
-              <a:t>Smart WMS Agent</a:t>
+              <a:t>WOONG AI</a:t>
             </a:r>
             <a:endParaRPr lang="en-US" sz="1100" dirty="0"/>
           </a:p>
@@ -13389,7 +13389,7 @@
                 <a:ea typeface="Malgun Gothic" pitchFamily="34" charset="-122"/>
                 <a:cs typeface="Malgun Gothic" pitchFamily="34" charset="-120"/>
               </a:rPr>
-              <a:t>Smart WMS Agent · Blackboard Auto-Execution Layer</a:t>
+              <a:t>WOONG AI · Blackboard Auto-Execution Layer</a:t>
             </a:r>
             <a:endParaRPr lang="en-US" sz="1100" dirty="0"/>
           </a:p>
@@ -25378,7 +25378,7 @@
                 <a:ea typeface="Malgun Gothic" pitchFamily="34" charset="-122"/>
                 <a:cs typeface="Malgun Gothic" pitchFamily="34" charset="-120"/>
               </a:rPr>
-              <a:t>Smart WMS Agent</a:t>
+              <a:t>WOONG AI</a:t>
             </a:r>
             <a:endParaRPr lang="en-US" sz="1100" dirty="0"/>
           </a:p>

</xml_diff>